<commit_message>
Aula 2 de LP
</commit_message>
<xml_diff>
--- a/UNIUBE-LP/Pratica_LP.pptx
+++ b/UNIUBE-LP/Pratica_LP.pptx
@@ -6,16 +6,15 @@
     <p:sldMasterId id="2147483684" r:id="rId2"/>
   </p:sldMasterIdLst>
   <p:notesMasterIdLst>
-    <p:notesMasterId r:id="rId10"/>
+    <p:notesMasterId r:id="rId9"/>
   </p:notesMasterIdLst>
   <p:sldIdLst>
     <p:sldId id="256" r:id="rId3"/>
     <p:sldId id="257" r:id="rId4"/>
-    <p:sldId id="259" r:id="rId5"/>
-    <p:sldId id="263" r:id="rId6"/>
+    <p:sldId id="263" r:id="rId5"/>
+    <p:sldId id="264" r:id="rId6"/>
     <p:sldId id="260" r:id="rId7"/>
-    <p:sldId id="261" r:id="rId8"/>
-    <p:sldId id="262" r:id="rId9"/>
+    <p:sldId id="262" r:id="rId8"/>
   </p:sldIdLst>
   <p:sldSz cx="12192000" cy="6858000"/>
   <p:notesSz cx="6858000" cy="9144000"/>
@@ -204,7 +203,7 @@
           <a:p>
             <a:fld id="{6ED03497-8374-466E-85FA-95E1138D8F6E}" type="datetimeFigureOut">
               <a:rPr lang="pt-BR" smtClean="0"/>
-              <a:t>04/08/2026</a:t>
+              <a:t>05/08/2026</a:t>
             </a:fld>
             <a:endParaRPr lang="pt-BR"/>
           </a:p>
@@ -1067,7 +1066,7 @@
         <p:cNvPr id="1" name="">
           <a:extLst>
             <a:ext uri="{FF2B5EF4-FFF2-40B4-BE49-F238E27FC236}">
-              <a16:creationId xmlns:a16="http://schemas.microsoft.com/office/drawing/2014/main" id="{D84C5A15-C07B-24C5-3F27-D602623D6E3A}"/>
+              <a16:creationId xmlns:a16="http://schemas.microsoft.com/office/drawing/2014/main" id="{E46C1DE5-178A-3E57-68D2-D30543490BC4}"/>
             </a:ext>
           </a:extLst>
         </p:cNvPr>
@@ -1087,7 +1086,7 @@
           <p:cNvPr id="2" name="Espaço Reservado para Imagem de Slide 1">
             <a:extLst>
               <a:ext uri="{FF2B5EF4-FFF2-40B4-BE49-F238E27FC236}">
-                <a16:creationId xmlns:a16="http://schemas.microsoft.com/office/drawing/2014/main" id="{82178E37-7E79-EE05-5571-FEC5BBECF003}"/>
+                <a16:creationId xmlns:a16="http://schemas.microsoft.com/office/drawing/2014/main" id="{BD81CF9E-1346-FA51-5738-9938E853E0FC}"/>
               </a:ext>
             </a:extLst>
           </p:cNvPr>
@@ -1105,7 +1104,7 @@
           <p:cNvPr id="3" name="Espaço Reservado para Anotações 2">
             <a:extLst>
               <a:ext uri="{FF2B5EF4-FFF2-40B4-BE49-F238E27FC236}">
-                <a16:creationId xmlns:a16="http://schemas.microsoft.com/office/drawing/2014/main" id="{5F16E796-A975-3669-4AAD-F48448C51829}"/>
+                <a16:creationId xmlns:a16="http://schemas.microsoft.com/office/drawing/2014/main" id="{287BFB6A-1332-8328-87A4-E0C5FE461F6D}"/>
               </a:ext>
             </a:extLst>
           </p:cNvPr>
@@ -1130,7 +1129,7 @@
           <p:cNvPr id="4" name="Espaço Reservado para Número de Slide 3">
             <a:extLst>
               <a:ext uri="{FF2B5EF4-FFF2-40B4-BE49-F238E27FC236}">
-                <a16:creationId xmlns:a16="http://schemas.microsoft.com/office/drawing/2014/main" id="{20242019-2F01-2BC8-1022-688E0CC0E1F8}"/>
+                <a16:creationId xmlns:a16="http://schemas.microsoft.com/office/drawing/2014/main" id="{C3D852B8-57B6-1E8E-4673-A687AD3C6C92}"/>
               </a:ext>
             </a:extLst>
           </p:cNvPr>
@@ -1157,7 +1156,7 @@
     </p:spTree>
     <p:extLst>
       <p:ext uri="{BB962C8B-B14F-4D97-AF65-F5344CB8AC3E}">
-        <p14:creationId xmlns:p14="http://schemas.microsoft.com/office/powerpoint/2010/main" val="3053127776"/>
+        <p14:creationId xmlns:p14="http://schemas.microsoft.com/office/powerpoint/2010/main" val="2272991715"/>
       </p:ext>
     </p:extLst>
   </p:cSld>
@@ -1175,7 +1174,7 @@
         <p:cNvPr id="1" name="">
           <a:extLst>
             <a:ext uri="{FF2B5EF4-FFF2-40B4-BE49-F238E27FC236}">
-              <a16:creationId xmlns:a16="http://schemas.microsoft.com/office/drawing/2014/main" id="{E46C1DE5-178A-3E57-68D2-D30543490BC4}"/>
+              <a16:creationId xmlns:a16="http://schemas.microsoft.com/office/drawing/2014/main" id="{72122B53-787E-9302-A471-C597B938EE65}"/>
             </a:ext>
           </a:extLst>
         </p:cNvPr>
@@ -1195,7 +1194,7 @@
           <p:cNvPr id="2" name="Espaço Reservado para Imagem de Slide 1">
             <a:extLst>
               <a:ext uri="{FF2B5EF4-FFF2-40B4-BE49-F238E27FC236}">
-                <a16:creationId xmlns:a16="http://schemas.microsoft.com/office/drawing/2014/main" id="{BD81CF9E-1346-FA51-5738-9938E853E0FC}"/>
+                <a16:creationId xmlns:a16="http://schemas.microsoft.com/office/drawing/2014/main" id="{6B847060-748E-B5B5-B8FF-E52F4365B37F}"/>
               </a:ext>
             </a:extLst>
           </p:cNvPr>
@@ -1213,7 +1212,7 @@
           <p:cNvPr id="3" name="Espaço Reservado para Anotações 2">
             <a:extLst>
               <a:ext uri="{FF2B5EF4-FFF2-40B4-BE49-F238E27FC236}">
-                <a16:creationId xmlns:a16="http://schemas.microsoft.com/office/drawing/2014/main" id="{287BFB6A-1332-8328-87A4-E0C5FE461F6D}"/>
+                <a16:creationId xmlns:a16="http://schemas.microsoft.com/office/drawing/2014/main" id="{47532CE1-C376-4771-1DF1-5043CA15B5CC}"/>
               </a:ext>
             </a:extLst>
           </p:cNvPr>
@@ -1238,7 +1237,7 @@
           <p:cNvPr id="4" name="Espaço Reservado para Número de Slide 3">
             <a:extLst>
               <a:ext uri="{FF2B5EF4-FFF2-40B4-BE49-F238E27FC236}">
-                <a16:creationId xmlns:a16="http://schemas.microsoft.com/office/drawing/2014/main" id="{C3D852B8-57B6-1E8E-4673-A687AD3C6C92}"/>
+                <a16:creationId xmlns:a16="http://schemas.microsoft.com/office/drawing/2014/main" id="{A4379AB0-9E0A-8F42-6734-D1F5AEF2D610}"/>
               </a:ext>
             </a:extLst>
           </p:cNvPr>
@@ -1265,7 +1264,7 @@
     </p:spTree>
     <p:extLst>
       <p:ext uri="{BB962C8B-B14F-4D97-AF65-F5344CB8AC3E}">
-        <p14:creationId xmlns:p14="http://schemas.microsoft.com/office/powerpoint/2010/main" val="2272991715"/>
+        <p14:creationId xmlns:p14="http://schemas.microsoft.com/office/powerpoint/2010/main" val="3624059957"/>
       </p:ext>
     </p:extLst>
   </p:cSld>
@@ -1391,114 +1390,6 @@
         <p:cNvPr id="1" name="">
           <a:extLst>
             <a:ext uri="{FF2B5EF4-FFF2-40B4-BE49-F238E27FC236}">
-              <a16:creationId xmlns:a16="http://schemas.microsoft.com/office/drawing/2014/main" id="{9B5756C6-DA53-1CCD-EE3C-2DA465BEA74D}"/>
-            </a:ext>
-          </a:extLst>
-        </p:cNvPr>
-        <p:cNvGrpSpPr/>
-        <p:nvPr/>
-      </p:nvGrpSpPr>
-      <p:grpSpPr>
-        <a:xfrm>
-          <a:off x="0" y="0"/>
-          <a:ext cx="0" cy="0"/>
-          <a:chOff x="0" y="0"/>
-          <a:chExt cx="0" cy="0"/>
-        </a:xfrm>
-      </p:grpSpPr>
-      <p:sp>
-        <p:nvSpPr>
-          <p:cNvPr id="2" name="Espaço Reservado para Imagem de Slide 1">
-            <a:extLst>
-              <a:ext uri="{FF2B5EF4-FFF2-40B4-BE49-F238E27FC236}">
-                <a16:creationId xmlns:a16="http://schemas.microsoft.com/office/drawing/2014/main" id="{65E90D32-32BC-7128-3AC8-1DE94C189480}"/>
-              </a:ext>
-            </a:extLst>
-          </p:cNvPr>
-          <p:cNvSpPr>
-            <a:spLocks noGrp="1" noRot="1" noChangeAspect="1"/>
-          </p:cNvSpPr>
-          <p:nvPr>
-            <p:ph type="sldImg"/>
-          </p:nvPr>
-        </p:nvSpPr>
-        <p:spPr/>
-      </p:sp>
-      <p:sp>
-        <p:nvSpPr>
-          <p:cNvPr id="3" name="Espaço Reservado para Anotações 2">
-            <a:extLst>
-              <a:ext uri="{FF2B5EF4-FFF2-40B4-BE49-F238E27FC236}">
-                <a16:creationId xmlns:a16="http://schemas.microsoft.com/office/drawing/2014/main" id="{7D0370FF-605D-DAD8-090F-C33ECB39D5D7}"/>
-              </a:ext>
-            </a:extLst>
-          </p:cNvPr>
-          <p:cNvSpPr>
-            <a:spLocks noGrp="1"/>
-          </p:cNvSpPr>
-          <p:nvPr>
-            <p:ph type="body" idx="1"/>
-          </p:nvPr>
-        </p:nvSpPr>
-        <p:spPr/>
-        <p:txBody>
-          <a:bodyPr/>
-          <a:lstStyle/>
-          <a:p>
-            <a:endParaRPr lang="pt-BR" dirty="0"/>
-          </a:p>
-        </p:txBody>
-      </p:sp>
-      <p:sp>
-        <p:nvSpPr>
-          <p:cNvPr id="4" name="Espaço Reservado para Número de Slide 3">
-            <a:extLst>
-              <a:ext uri="{FF2B5EF4-FFF2-40B4-BE49-F238E27FC236}">
-                <a16:creationId xmlns:a16="http://schemas.microsoft.com/office/drawing/2014/main" id="{D2A5E8FF-8FDE-9763-9DD0-2CFEC62B47CB}"/>
-              </a:ext>
-            </a:extLst>
-          </p:cNvPr>
-          <p:cNvSpPr>
-            <a:spLocks noGrp="1"/>
-          </p:cNvSpPr>
-          <p:nvPr>
-            <p:ph type="sldNum" sz="quarter" idx="5"/>
-          </p:nvPr>
-        </p:nvSpPr>
-        <p:spPr/>
-        <p:txBody>
-          <a:bodyPr/>
-          <a:lstStyle/>
-          <a:p>
-            <a:fld id="{80F36A49-A1DD-40F8-B8AD-E6F5365256CB}" type="slidenum">
-              <a:rPr lang="pt-BR" smtClean="0"/>
-              <a:t>6</a:t>
-            </a:fld>
-            <a:endParaRPr lang="pt-BR"/>
-          </a:p>
-        </p:txBody>
-      </p:sp>
-    </p:spTree>
-    <p:extLst>
-      <p:ext uri="{BB962C8B-B14F-4D97-AF65-F5344CB8AC3E}">
-        <p14:creationId xmlns:p14="http://schemas.microsoft.com/office/powerpoint/2010/main" val="1078943847"/>
-      </p:ext>
-    </p:extLst>
-  </p:cSld>
-  <p:clrMapOvr>
-    <a:masterClrMapping/>
-  </p:clrMapOvr>
-</p:notes>
-</file>
-
-<file path=ppt/notesSlides/notesSlide7.xml><?xml version="1.0" encoding="utf-8"?>
-<p:notes xmlns:a="http://schemas.openxmlformats.org/drawingml/2006/main" xmlns:r="http://schemas.openxmlformats.org/officeDocument/2006/relationships" xmlns:p="http://schemas.openxmlformats.org/presentationml/2006/main">
-  <p:cSld>
-    <p:spTree>
-      <p:nvGrpSpPr>
-        <p:cNvPr id="1" name="">
-          <a:extLst>
-            <a:ext uri="{FF2B5EF4-FFF2-40B4-BE49-F238E27FC236}">
               <a16:creationId xmlns:a16="http://schemas.microsoft.com/office/drawing/2014/main" id="{25167C8E-04E0-3D97-2244-E307A94EEB7F}"/>
             </a:ext>
           </a:extLst>
@@ -1580,7 +1471,7 @@
           <a:p>
             <a:fld id="{80F36A49-A1DD-40F8-B8AD-E6F5365256CB}" type="slidenum">
               <a:rPr lang="pt-BR" smtClean="0"/>
-              <a:t>7</a:t>
+              <a:t>6</a:t>
             </a:fld>
             <a:endParaRPr lang="pt-BR"/>
           </a:p>
@@ -1746,7 +1637,7 @@
           <a:p>
             <a:fld id="{A87E3B6E-8316-4A1C-BADA-DB7F3456EEF1}" type="datetimeFigureOut">
               <a:rPr lang="pt-BR" smtClean="0"/>
-              <a:t>04/08/2026</a:t>
+              <a:t>05/08/2026</a:t>
             </a:fld>
             <a:endParaRPr lang="pt-BR"/>
           </a:p>
@@ -1944,7 +1835,7 @@
           <a:p>
             <a:fld id="{A87E3B6E-8316-4A1C-BADA-DB7F3456EEF1}" type="datetimeFigureOut">
               <a:rPr lang="pt-BR" smtClean="0"/>
-              <a:t>04/08/2026</a:t>
+              <a:t>05/08/2026</a:t>
             </a:fld>
             <a:endParaRPr lang="pt-BR"/>
           </a:p>
@@ -2152,7 +2043,7 @@
           <a:p>
             <a:fld id="{A87E3B6E-8316-4A1C-BADA-DB7F3456EEF1}" type="datetimeFigureOut">
               <a:rPr lang="pt-BR" smtClean="0"/>
-              <a:t>04/08/2026</a:t>
+              <a:t>05/08/2026</a:t>
             </a:fld>
             <a:endParaRPr lang="pt-BR"/>
           </a:p>
@@ -2388,7 +2279,7 @@
           <a:p>
             <a:fld id="{A87E3B6E-8316-4A1C-BADA-DB7F3456EEF1}" type="datetimeFigureOut">
               <a:rPr lang="pt-BR" smtClean="0"/>
-              <a:t>04/08/2026</a:t>
+              <a:t>05/08/2026</a:t>
             </a:fld>
             <a:endParaRPr lang="pt-BR"/>
           </a:p>
@@ -2558,7 +2449,7 @@
           <a:p>
             <a:fld id="{A87E3B6E-8316-4A1C-BADA-DB7F3456EEF1}" type="datetimeFigureOut">
               <a:rPr lang="pt-BR" smtClean="0"/>
-              <a:t>04/08/2026</a:t>
+              <a:t>05/08/2026</a:t>
             </a:fld>
             <a:endParaRPr lang="pt-BR"/>
           </a:p>
@@ -2826,7 +2717,7 @@
           <a:p>
             <a:fld id="{A87E3B6E-8316-4A1C-BADA-DB7F3456EEF1}" type="datetimeFigureOut">
               <a:rPr lang="pt-BR" smtClean="0"/>
-              <a:t>04/08/2026</a:t>
+              <a:t>05/08/2026</a:t>
             </a:fld>
             <a:endParaRPr lang="pt-BR"/>
           </a:p>
@@ -3058,7 +2949,7 @@
           <a:p>
             <a:fld id="{A87E3B6E-8316-4A1C-BADA-DB7F3456EEF1}" type="datetimeFigureOut">
               <a:rPr lang="pt-BR" smtClean="0"/>
-              <a:t>04/08/2026</a:t>
+              <a:t>05/08/2026</a:t>
             </a:fld>
             <a:endParaRPr lang="pt-BR"/>
           </a:p>
@@ -3413,7 +3304,7 @@
           <a:p>
             <a:fld id="{A87E3B6E-8316-4A1C-BADA-DB7F3456EEF1}" type="datetimeFigureOut">
               <a:rPr lang="pt-BR" smtClean="0"/>
-              <a:t>04/08/2026</a:t>
+              <a:t>05/08/2026</a:t>
             </a:fld>
             <a:endParaRPr lang="pt-BR"/>
           </a:p>
@@ -3554,7 +3445,7 @@
           <a:p>
             <a:fld id="{A87E3B6E-8316-4A1C-BADA-DB7F3456EEF1}" type="datetimeFigureOut">
               <a:rPr lang="pt-BR" smtClean="0"/>
-              <a:t>04/08/2026</a:t>
+              <a:t>05/08/2026</a:t>
             </a:fld>
             <a:endParaRPr lang="pt-BR"/>
           </a:p>
@@ -3649,7 +3540,7 @@
           <a:p>
             <a:fld id="{A87E3B6E-8316-4A1C-BADA-DB7F3456EEF1}" type="datetimeFigureOut">
               <a:rPr lang="pt-BR" smtClean="0"/>
-              <a:t>04/08/2026</a:t>
+              <a:t>05/08/2026</a:t>
             </a:fld>
             <a:endParaRPr lang="pt-BR"/>
           </a:p>
@@ -4006,7 +3897,7 @@
           <a:p>
             <a:fld id="{A87E3B6E-8316-4A1C-BADA-DB7F3456EEF1}" type="datetimeFigureOut">
               <a:rPr lang="pt-BR" smtClean="0"/>
-              <a:t>04/08/2026</a:t>
+              <a:t>05/08/2026</a:t>
             </a:fld>
             <a:endParaRPr lang="pt-BR"/>
           </a:p>
@@ -4207,7 +4098,7 @@
           <a:p>
             <a:fld id="{A87E3B6E-8316-4A1C-BADA-DB7F3456EEF1}" type="datetimeFigureOut">
               <a:rPr lang="pt-BR" smtClean="0"/>
-              <a:t>04/08/2026</a:t>
+              <a:t>05/08/2026</a:t>
             </a:fld>
             <a:endParaRPr lang="pt-BR"/>
           </a:p>
@@ -4560,7 +4451,7 @@
           <a:p>
             <a:fld id="{A87E3B6E-8316-4A1C-BADA-DB7F3456EEF1}" type="datetimeFigureOut">
               <a:rPr lang="pt-BR" smtClean="0"/>
-              <a:t>04/08/2026</a:t>
+              <a:t>05/08/2026</a:t>
             </a:fld>
             <a:endParaRPr lang="pt-BR"/>
           </a:p>
@@ -4745,7 +4636,7 @@
           <a:p>
             <a:fld id="{A87E3B6E-8316-4A1C-BADA-DB7F3456EEF1}" type="datetimeFigureOut">
               <a:rPr lang="pt-BR" smtClean="0"/>
-              <a:t>04/08/2026</a:t>
+              <a:t>05/08/2026</a:t>
             </a:fld>
             <a:endParaRPr lang="pt-BR"/>
           </a:p>
@@ -4925,7 +4816,7 @@
           <a:p>
             <a:fld id="{A87E3B6E-8316-4A1C-BADA-DB7F3456EEF1}" type="datetimeFigureOut">
               <a:rPr lang="pt-BR" smtClean="0"/>
-              <a:t>04/08/2026</a:t>
+              <a:t>05/08/2026</a:t>
             </a:fld>
             <a:endParaRPr lang="pt-BR"/>
           </a:p>
@@ -5188,7 +5079,7 @@
           <a:p>
             <a:fld id="{A87E3B6E-8316-4A1C-BADA-DB7F3456EEF1}" type="datetimeFigureOut">
               <a:rPr lang="pt-BR" smtClean="0"/>
-              <a:t>04/08/2026</a:t>
+              <a:t>05/08/2026</a:t>
             </a:fld>
             <a:endParaRPr lang="pt-BR"/>
           </a:p>
@@ -5453,7 +5344,7 @@
           <a:p>
             <a:fld id="{A87E3B6E-8316-4A1C-BADA-DB7F3456EEF1}" type="datetimeFigureOut">
               <a:rPr lang="pt-BR" smtClean="0"/>
-              <a:t>04/08/2026</a:t>
+              <a:t>05/08/2026</a:t>
             </a:fld>
             <a:endParaRPr lang="pt-BR"/>
           </a:p>
@@ -5865,7 +5756,7 @@
           <a:p>
             <a:fld id="{A87E3B6E-8316-4A1C-BADA-DB7F3456EEF1}" type="datetimeFigureOut">
               <a:rPr lang="pt-BR" smtClean="0"/>
-              <a:t>04/08/2026</a:t>
+              <a:t>05/08/2026</a:t>
             </a:fld>
             <a:endParaRPr lang="pt-BR"/>
           </a:p>
@@ -6006,7 +5897,7 @@
           <a:p>
             <a:fld id="{A87E3B6E-8316-4A1C-BADA-DB7F3456EEF1}" type="datetimeFigureOut">
               <a:rPr lang="pt-BR" smtClean="0"/>
-              <a:t>04/08/2026</a:t>
+              <a:t>05/08/2026</a:t>
             </a:fld>
             <a:endParaRPr lang="pt-BR"/>
           </a:p>
@@ -6119,7 +6010,7 @@
           <a:p>
             <a:fld id="{A87E3B6E-8316-4A1C-BADA-DB7F3456EEF1}" type="datetimeFigureOut">
               <a:rPr lang="pt-BR" smtClean="0"/>
-              <a:t>04/08/2026</a:t>
+              <a:t>05/08/2026</a:t>
             </a:fld>
             <a:endParaRPr lang="pt-BR"/>
           </a:p>
@@ -6430,7 +6321,7 @@
           <a:p>
             <a:fld id="{A87E3B6E-8316-4A1C-BADA-DB7F3456EEF1}" type="datetimeFigureOut">
               <a:rPr lang="pt-BR" smtClean="0"/>
-              <a:t>04/08/2026</a:t>
+              <a:t>05/08/2026</a:t>
             </a:fld>
             <a:endParaRPr lang="pt-BR"/>
           </a:p>
@@ -6718,7 +6609,7 @@
           <a:p>
             <a:fld id="{A87E3B6E-8316-4A1C-BADA-DB7F3456EEF1}" type="datetimeFigureOut">
               <a:rPr lang="pt-BR" smtClean="0"/>
-              <a:t>04/08/2026</a:t>
+              <a:t>05/08/2026</a:t>
             </a:fld>
             <a:endParaRPr lang="pt-BR"/>
           </a:p>
@@ -6959,7 +6850,7 @@
           <a:p>
             <a:fld id="{A87E3B6E-8316-4A1C-BADA-DB7F3456EEF1}" type="datetimeFigureOut">
               <a:rPr lang="pt-BR" smtClean="0"/>
-              <a:t>04/08/2026</a:t>
+              <a:t>05/08/2026</a:t>
             </a:fld>
             <a:endParaRPr lang="pt-BR"/>
           </a:p>
@@ -7523,7 +7414,7 @@
           <a:p>
             <a:fld id="{A87E3B6E-8316-4A1C-BADA-DB7F3456EEF1}" type="datetimeFigureOut">
               <a:rPr lang="pt-BR" smtClean="0"/>
-              <a:t>04/08/2026</a:t>
+              <a:t>05/08/2026</a:t>
             </a:fld>
             <a:endParaRPr lang="pt-BR"/>
           </a:p>
@@ -8378,7 +8269,7 @@
         <p:cNvPr id="1" name="">
           <a:extLst>
             <a:ext uri="{FF2B5EF4-FFF2-40B4-BE49-F238E27FC236}">
-              <a16:creationId xmlns:a16="http://schemas.microsoft.com/office/drawing/2014/main" id="{259A2F58-1128-558F-DCB1-7CF05670E300}"/>
+              <a16:creationId xmlns:a16="http://schemas.microsoft.com/office/drawing/2014/main" id="{49593742-E9D6-2509-AB5A-0253CF192376}"/>
             </a:ext>
           </a:extLst>
         </p:cNvPr>
@@ -8398,7 +8289,7 @@
           <p:cNvPr id="5" name="Retângulo 4">
             <a:extLst>
               <a:ext uri="{FF2B5EF4-FFF2-40B4-BE49-F238E27FC236}">
-                <a16:creationId xmlns:a16="http://schemas.microsoft.com/office/drawing/2014/main" id="{D6DF6645-7FCB-940C-5293-F3BFFAEFF093}"/>
+                <a16:creationId xmlns:a16="http://schemas.microsoft.com/office/drawing/2014/main" id="{77DA3C8A-A088-1554-29EF-51BCDBBF1A67}"/>
               </a:ext>
             </a:extLst>
           </p:cNvPr>
@@ -8452,7 +8343,7 @@
           <p:cNvPr id="2" name="Título 1">
             <a:extLst>
               <a:ext uri="{FF2B5EF4-FFF2-40B4-BE49-F238E27FC236}">
-                <a16:creationId xmlns:a16="http://schemas.microsoft.com/office/drawing/2014/main" id="{788ADE5A-73D6-C583-50B8-F1890292E5E6}"/>
+                <a16:creationId xmlns:a16="http://schemas.microsoft.com/office/drawing/2014/main" id="{C2AF1174-76FB-C1EF-061C-765DB6774BDA}"/>
               </a:ext>
             </a:extLst>
           </p:cNvPr>
@@ -8480,7 +8371,7 @@
                   <a:schemeClr val="bg1"/>
                 </a:solidFill>
               </a:rPr>
-              <a:t>Prática 1 - Notas</a:t>
+              <a:t>Prática 2 - Notas</a:t>
             </a:r>
           </a:p>
         </p:txBody>
@@ -8490,7 +8381,7 @@
           <p:cNvPr id="12" name="AutoShape 6" descr="Lógica Proposicional x Lógica de Argumento ⋆ Colaborae">
             <a:extLst>
               <a:ext uri="{FF2B5EF4-FFF2-40B4-BE49-F238E27FC236}">
-                <a16:creationId xmlns:a16="http://schemas.microsoft.com/office/drawing/2014/main" id="{46852B17-015C-E123-FC08-09AFB87146CC}"/>
+                <a16:creationId xmlns:a16="http://schemas.microsoft.com/office/drawing/2014/main" id="{F87DD3E7-4408-7230-061F-0739D164DA24}"/>
               </a:ext>
             </a:extLst>
           </p:cNvPr>
@@ -8535,7 +8426,7 @@
           <p:cNvPr id="4" name="Espaço Reservado para Conteúdo 3">
             <a:extLst>
               <a:ext uri="{FF2B5EF4-FFF2-40B4-BE49-F238E27FC236}">
-                <a16:creationId xmlns:a16="http://schemas.microsoft.com/office/drawing/2014/main" id="{7532ABCF-04C7-B53F-E1BF-EC3FAE10748E}"/>
+                <a16:creationId xmlns:a16="http://schemas.microsoft.com/office/drawing/2014/main" id="{78CE2E25-18C9-658F-01F2-FD746C1C092C}"/>
               </a:ext>
             </a:extLst>
           </p:cNvPr>
@@ -8546,94 +8437,138 @@
             <p:ph idx="1"/>
           </p:nvPr>
         </p:nvSpPr>
-        <p:spPr/>
-        <p:txBody>
-          <a:bodyPr/>
-          <a:lstStyle/>
-          <a:p>
-            <a:r>
-              <a:rPr lang="pt-BR" sz="2400" b="1" dirty="0"/>
-              <a:t>Programa: </a:t>
-            </a:r>
-            <a:r>
-              <a:rPr lang="pt-BR" sz="2400" b="1" dirty="0" err="1"/>
-              <a:t>Hello</a:t>
-            </a:r>
-            <a:r>
-              <a:rPr lang="pt-BR" sz="2400" b="1" dirty="0"/>
-              <a:t> World</a:t>
-            </a:r>
-          </a:p>
-          <a:p>
-            <a:endParaRPr lang="pt-BR" sz="2400" dirty="0"/>
-          </a:p>
-          <a:p>
-            <a:r>
-              <a:rPr lang="pt-BR" sz="2400" dirty="0"/>
-              <a:t>As palavras reservadas em C são termos com funções fixas na linguagem, como </a:t>
-            </a:r>
-            <a:r>
-              <a:rPr lang="pt-BR" sz="2400" b="1" dirty="0" err="1"/>
-              <a:t>int</a:t>
-            </a:r>
-            <a:r>
-              <a:rPr lang="pt-BR" sz="2400" dirty="0"/>
-              <a:t>, </a:t>
-            </a:r>
-            <a:r>
-              <a:rPr lang="pt-BR" sz="2400" b="1" dirty="0" err="1"/>
-              <a:t>if</a:t>
-            </a:r>
-            <a:r>
-              <a:rPr lang="pt-BR" sz="2400" dirty="0"/>
-              <a:t> e </a:t>
-            </a:r>
-            <a:r>
-              <a:rPr lang="pt-BR" sz="2400" b="1" dirty="0" err="1"/>
-              <a:t>return</a:t>
-            </a:r>
-            <a:r>
-              <a:rPr lang="pt-BR" sz="2400" dirty="0"/>
-              <a:t>. Elas somam 32 no padrão original e não podem ser usadas para dar nomes a variáveis ou funções.</a:t>
-            </a:r>
-            <a:endParaRPr lang="en-US" sz="2400" dirty="0"/>
-          </a:p>
-        </p:txBody>
-      </p:sp>
-      <p:pic>
-        <p:nvPicPr>
-          <p:cNvPr id="3" name="Imagem 2">
-            <a:extLst>
-              <a:ext uri="{FF2B5EF4-FFF2-40B4-BE49-F238E27FC236}">
-                <a16:creationId xmlns:a16="http://schemas.microsoft.com/office/drawing/2014/main" id="{7EAA4320-0DEB-C5C5-FFEB-5747E676314E}"/>
-              </a:ext>
-            </a:extLst>
-          </p:cNvPr>
-          <p:cNvPicPr>
-            <a:picLocks noChangeAspect="1"/>
-          </p:cNvPicPr>
-          <p:nvPr/>
-        </p:nvPicPr>
-        <p:blipFill>
-          <a:blip r:embed="rId3"/>
-          <a:stretch>
-            <a:fillRect/>
-          </a:stretch>
-        </p:blipFill>
         <p:spPr>
           <a:xfrm>
-            <a:off x="2752044" y="4081463"/>
-            <a:ext cx="6687911" cy="2658651"/>
+            <a:off x="838200" y="1622424"/>
+            <a:ext cx="10515600" cy="5032375"/>
           </a:xfrm>
-          <a:prstGeom prst="rect">
-            <a:avLst/>
-          </a:prstGeom>
         </p:spPr>
-      </p:pic>
+        <p:txBody>
+          <a:bodyPr/>
+          <a:lstStyle/>
+          <a:p>
+            <a:r>
+              <a:rPr lang="pt-BR" sz="2400" b="1" dirty="0"/>
+              <a:t>Programa: Variáveis e constantes</a:t>
+            </a:r>
+          </a:p>
+          <a:p>
+            <a:endParaRPr lang="pt-BR" sz="2400" b="1" dirty="0"/>
+          </a:p>
+          <a:p>
+            <a:r>
+              <a:rPr lang="pt-BR" sz="2200" b="1" dirty="0" err="1"/>
+              <a:t>signed</a:t>
+            </a:r>
+            <a:r>
+              <a:rPr lang="pt-BR" sz="2200" b="1" dirty="0"/>
+              <a:t> e </a:t>
+            </a:r>
+            <a:r>
+              <a:rPr lang="pt-BR" sz="2200" b="1" dirty="0" err="1"/>
+              <a:t>unsigned</a:t>
+            </a:r>
+            <a:r>
+              <a:rPr lang="pt-BR" sz="2200" b="1" dirty="0"/>
+              <a:t>: </a:t>
+            </a:r>
+            <a:r>
+              <a:rPr lang="pt-BR" sz="2200" dirty="0"/>
+              <a:t>Não funcionam com </a:t>
+            </a:r>
+            <a:r>
+              <a:rPr lang="pt-BR" sz="2200" dirty="0" err="1"/>
+              <a:t>float</a:t>
+            </a:r>
+            <a:r>
+              <a:rPr lang="pt-BR" sz="2200" dirty="0"/>
+              <a:t>. Esses modificadores servem apenas para tipos inteiros (</a:t>
+            </a:r>
+            <a:r>
+              <a:rPr lang="pt-BR" sz="2200" dirty="0" err="1"/>
+              <a:t>int</a:t>
+            </a:r>
+            <a:r>
+              <a:rPr lang="pt-BR" sz="2200" dirty="0"/>
+              <a:t>) e caracteres (char), pois definem a presença ou ausência de sinal matemático no armazenamento binário dos bits.</a:t>
+            </a:r>
+          </a:p>
+          <a:p>
+            <a:endParaRPr lang="pt-BR" sz="2200" dirty="0"/>
+          </a:p>
+          <a:p>
+            <a:r>
+              <a:rPr lang="pt-BR" sz="2200" dirty="0"/>
+              <a:t>Os números </a:t>
+            </a:r>
+            <a:r>
+              <a:rPr lang="pt-BR" sz="2200" dirty="0" err="1"/>
+              <a:t>float</a:t>
+            </a:r>
+            <a:r>
+              <a:rPr lang="pt-BR" sz="2200" dirty="0"/>
+              <a:t> já possuem nativamente um bit dedicado ao sinal.</a:t>
+            </a:r>
+          </a:p>
+          <a:p>
+            <a:endParaRPr lang="pt-BR" sz="2200" dirty="0"/>
+          </a:p>
+          <a:p>
+            <a:r>
+              <a:rPr lang="pt-BR" sz="2200" dirty="0"/>
+              <a:t> Não existe “</a:t>
+            </a:r>
+            <a:r>
+              <a:rPr lang="pt-BR" sz="2200" i="1" dirty="0"/>
+              <a:t>short </a:t>
+            </a:r>
+            <a:r>
+              <a:rPr lang="pt-BR" sz="2200" i="1" dirty="0" err="1"/>
+              <a:t>float</a:t>
+            </a:r>
+            <a:r>
+              <a:rPr lang="pt-BR" sz="2200" i="1" dirty="0"/>
+              <a:t>” </a:t>
+            </a:r>
+            <a:r>
+              <a:rPr lang="pt-BR" sz="2200" dirty="0"/>
+              <a:t>em C, mas a linguagem permite o uso de “</a:t>
+            </a:r>
+            <a:r>
+              <a:rPr lang="pt-BR" sz="2200" i="1" dirty="0" err="1"/>
+              <a:t>long</a:t>
+            </a:r>
+            <a:r>
+              <a:rPr lang="pt-BR" sz="2200" i="1" dirty="0"/>
+              <a:t> </a:t>
+            </a:r>
+            <a:r>
+              <a:rPr lang="pt-BR" sz="2200" i="1" dirty="0" err="1"/>
+              <a:t>double</a:t>
+            </a:r>
+            <a:r>
+              <a:rPr lang="pt-BR" sz="2200" i="1" dirty="0"/>
+              <a:t>” </a:t>
+            </a:r>
+            <a:r>
+              <a:rPr lang="pt-BR" sz="2200" dirty="0"/>
+              <a:t>para criar um tipo de ponto flutuante com precisão ainda maior que o “</a:t>
+            </a:r>
+            <a:r>
+              <a:rPr lang="pt-BR" sz="2200" i="1" dirty="0" err="1"/>
+              <a:t>double</a:t>
+            </a:r>
+            <a:r>
+              <a:rPr lang="pt-BR" sz="2200" i="1" dirty="0"/>
+              <a:t>”</a:t>
+            </a:r>
+          </a:p>
+        </p:txBody>
+      </p:sp>
     </p:spTree>
     <p:extLst>
       <p:ext uri="{BB962C8B-B14F-4D97-AF65-F5344CB8AC3E}">
-        <p14:creationId xmlns:p14="http://schemas.microsoft.com/office/powerpoint/2010/main" val="1237600533"/>
+        <p14:creationId xmlns:p14="http://schemas.microsoft.com/office/powerpoint/2010/main" val="2701370184"/>
       </p:ext>
     </p:extLst>
   </p:cSld>
@@ -8651,7 +8586,7 @@
         <p:cNvPr id="1" name="">
           <a:extLst>
             <a:ext uri="{FF2B5EF4-FFF2-40B4-BE49-F238E27FC236}">
-              <a16:creationId xmlns:a16="http://schemas.microsoft.com/office/drawing/2014/main" id="{49593742-E9D6-2509-AB5A-0253CF192376}"/>
+              <a16:creationId xmlns:a16="http://schemas.microsoft.com/office/drawing/2014/main" id="{7C0D460E-AC35-2E6E-197D-4DAE6A7AF01C}"/>
             </a:ext>
           </a:extLst>
         </p:cNvPr>
@@ -8671,7 +8606,7 @@
           <p:cNvPr id="5" name="Retângulo 4">
             <a:extLst>
               <a:ext uri="{FF2B5EF4-FFF2-40B4-BE49-F238E27FC236}">
-                <a16:creationId xmlns:a16="http://schemas.microsoft.com/office/drawing/2014/main" id="{77DA3C8A-A088-1554-29EF-51BCDBBF1A67}"/>
+                <a16:creationId xmlns:a16="http://schemas.microsoft.com/office/drawing/2014/main" id="{F1237934-8420-F3C3-00B3-B64B09245560}"/>
               </a:ext>
             </a:extLst>
           </p:cNvPr>
@@ -8725,7 +8660,7 @@
           <p:cNvPr id="2" name="Título 1">
             <a:extLst>
               <a:ext uri="{FF2B5EF4-FFF2-40B4-BE49-F238E27FC236}">
-                <a16:creationId xmlns:a16="http://schemas.microsoft.com/office/drawing/2014/main" id="{C2AF1174-76FB-C1EF-061C-765DB6774BDA}"/>
+                <a16:creationId xmlns:a16="http://schemas.microsoft.com/office/drawing/2014/main" id="{8050FB70-0CDA-5D99-C426-33B4F3E40A75}"/>
               </a:ext>
             </a:extLst>
           </p:cNvPr>
@@ -8763,7 +8698,7 @@
           <p:cNvPr id="12" name="AutoShape 6" descr="Lógica Proposicional x Lógica de Argumento ⋆ Colaborae">
             <a:extLst>
               <a:ext uri="{FF2B5EF4-FFF2-40B4-BE49-F238E27FC236}">
-                <a16:creationId xmlns:a16="http://schemas.microsoft.com/office/drawing/2014/main" id="{F87DD3E7-4408-7230-061F-0739D164DA24}"/>
+                <a16:creationId xmlns:a16="http://schemas.microsoft.com/office/drawing/2014/main" id="{3E632FAF-182B-4729-DEEE-0921A1984147}"/>
               </a:ext>
             </a:extLst>
           </p:cNvPr>
@@ -8808,7 +8743,7 @@
           <p:cNvPr id="4" name="Espaço Reservado para Conteúdo 3">
             <a:extLst>
               <a:ext uri="{FF2B5EF4-FFF2-40B4-BE49-F238E27FC236}">
-                <a16:creationId xmlns:a16="http://schemas.microsoft.com/office/drawing/2014/main" id="{78CE2E25-18C9-658F-01F2-FD746C1C092C}"/>
+                <a16:creationId xmlns:a16="http://schemas.microsoft.com/office/drawing/2014/main" id="{6D514F02-E7EE-EEBD-406C-BEE1FC10FC52}"/>
               </a:ext>
             </a:extLst>
           </p:cNvPr>
@@ -8839,118 +8774,273 @@
           </a:p>
           <a:p>
             <a:r>
-              <a:rPr lang="pt-BR" sz="2200" b="1" dirty="0" err="1"/>
-              <a:t>signed</a:t>
-            </a:r>
-            <a:r>
-              <a:rPr lang="pt-BR" sz="2200" b="1" dirty="0"/>
-              <a:t> e </a:t>
-            </a:r>
-            <a:r>
-              <a:rPr lang="pt-BR" sz="2200" b="1" dirty="0" err="1"/>
-              <a:t>unsigned</a:t>
-            </a:r>
-            <a:r>
-              <a:rPr lang="pt-BR" sz="2200" b="1" dirty="0"/>
-              <a:t>: </a:t>
-            </a:r>
-            <a:r>
               <a:rPr lang="pt-BR" sz="2200" dirty="0"/>
-              <a:t>Não funcionam com </a:t>
-            </a:r>
-            <a:r>
-              <a:rPr lang="pt-BR" sz="2200" dirty="0" err="1"/>
-              <a:t>float</a:t>
-            </a:r>
-            <a:r>
-              <a:rPr lang="pt-BR" sz="2200" dirty="0"/>
-              <a:t>. Esses modificadores servem apenas para tipos inteiros (</a:t>
-            </a:r>
-            <a:r>
-              <a:rPr lang="pt-BR" sz="2200" dirty="0" err="1"/>
-              <a:t>int</a:t>
-            </a:r>
-            <a:r>
-              <a:rPr lang="pt-BR" sz="2200" dirty="0"/>
-              <a:t>) e caracteres (char), pois definem a presença ou ausência de sinal matemático no armazenamento binário dos bits.</a:t>
+              <a:t>Especificadores de formato são códigos iniciados por % usados para indicar o tipo de dado que o programa vai ler ou mostrar na tela. São eles:</a:t>
+            </a:r>
+          </a:p>
+          <a:p>
+            <a:pPr lvl="1"/>
+            <a:endParaRPr lang="pt-BR" sz="1800" dirty="0"/>
+          </a:p>
+          <a:p>
+            <a:pPr lvl="1"/>
+            <a:r>
+              <a:rPr lang="pt-BR" sz="1800" b="1" dirty="0"/>
+              <a:t>%d (ou %i) </a:t>
+            </a:r>
+            <a:r>
+              <a:rPr lang="pt-BR" sz="1800" dirty="0">
+                <a:latin typeface="Calibri" panose="020F0502020204030204" pitchFamily="34" charset="0"/>
+                <a:ea typeface="Calibri" panose="020F0502020204030204" pitchFamily="34" charset="0"/>
+                <a:cs typeface="Calibri" panose="020F0502020204030204" pitchFamily="34" charset="0"/>
+              </a:rPr>
+              <a:t>→</a:t>
+            </a:r>
+            <a:r>
+              <a:rPr lang="pt-BR" sz="1800" b="1" dirty="0">
+                <a:latin typeface="Calibri" panose="020F0502020204030204" pitchFamily="34" charset="0"/>
+                <a:ea typeface="Calibri" panose="020F0502020204030204" pitchFamily="34" charset="0"/>
+                <a:cs typeface="Calibri" panose="020F0502020204030204" pitchFamily="34" charset="0"/>
+              </a:rPr>
+              <a:t> </a:t>
+            </a:r>
+            <a:r>
+              <a:rPr lang="pt-BR" sz="1800" dirty="0"/>
+              <a:t>Número inteiro decimal</a:t>
+            </a:r>
+            <a:endParaRPr lang="pt-BR" sz="1800" b="1" dirty="0"/>
+          </a:p>
+          <a:p>
+            <a:pPr lvl="1"/>
+            <a:r>
+              <a:rPr lang="pt-BR" sz="1800" b="1" dirty="0"/>
+              <a:t>%f </a:t>
+            </a:r>
+            <a:r>
+              <a:rPr lang="pt-BR" sz="1800" dirty="0">
+                <a:latin typeface="Calibri" panose="020F0502020204030204" pitchFamily="34" charset="0"/>
+                <a:ea typeface="Calibri" panose="020F0502020204030204" pitchFamily="34" charset="0"/>
+                <a:cs typeface="Calibri" panose="020F0502020204030204" pitchFamily="34" charset="0"/>
+              </a:rPr>
+              <a:t>→</a:t>
+            </a:r>
+            <a:r>
+              <a:rPr lang="pt-BR" sz="1800" b="1" dirty="0">
+                <a:latin typeface="Calibri" panose="020F0502020204030204" pitchFamily="34" charset="0"/>
+                <a:ea typeface="Calibri" panose="020F0502020204030204" pitchFamily="34" charset="0"/>
+                <a:cs typeface="Calibri" panose="020F0502020204030204" pitchFamily="34" charset="0"/>
+              </a:rPr>
+              <a:t> </a:t>
+            </a:r>
+            <a:r>
+              <a:rPr lang="pt-BR" sz="1800" dirty="0"/>
+              <a:t>Número real de ponto flutuante</a:t>
+            </a:r>
+            <a:endParaRPr lang="pt-BR" sz="1800" b="1" dirty="0"/>
+          </a:p>
+          <a:p>
+            <a:pPr lvl="1"/>
+            <a:r>
+              <a:rPr lang="pt-BR" sz="1800" b="1" dirty="0"/>
+              <a:t>%</a:t>
+            </a:r>
+            <a:r>
+              <a:rPr lang="pt-BR" sz="1800" b="1" dirty="0" err="1"/>
+              <a:t>lf</a:t>
+            </a:r>
+            <a:r>
+              <a:rPr lang="pt-BR" sz="1800" b="1" dirty="0"/>
+              <a:t> </a:t>
+            </a:r>
+            <a:r>
+              <a:rPr lang="pt-BR" sz="1800" dirty="0">
+                <a:latin typeface="Calibri" panose="020F0502020204030204" pitchFamily="34" charset="0"/>
+                <a:ea typeface="Calibri" panose="020F0502020204030204" pitchFamily="34" charset="0"/>
+                <a:cs typeface="Calibri" panose="020F0502020204030204" pitchFamily="34" charset="0"/>
+              </a:rPr>
+              <a:t>→</a:t>
+            </a:r>
+            <a:r>
+              <a:rPr lang="pt-BR" sz="1800" b="1" dirty="0">
+                <a:latin typeface="Calibri" panose="020F0502020204030204" pitchFamily="34" charset="0"/>
+                <a:ea typeface="Calibri" panose="020F0502020204030204" pitchFamily="34" charset="0"/>
+                <a:cs typeface="Calibri" panose="020F0502020204030204" pitchFamily="34" charset="0"/>
+              </a:rPr>
+              <a:t> </a:t>
+            </a:r>
+            <a:r>
+              <a:rPr lang="pt-BR" sz="1800" dirty="0"/>
+              <a:t>Número real de dupla precisão (</a:t>
+            </a:r>
+            <a:r>
+              <a:rPr lang="pt-BR" sz="1800" dirty="0" err="1"/>
+              <a:t>double</a:t>
+            </a:r>
+            <a:r>
+              <a:rPr lang="pt-BR" sz="1800" dirty="0"/>
+              <a:t>)</a:t>
+            </a:r>
+            <a:endParaRPr lang="pt-BR" sz="1800" b="1" dirty="0"/>
+          </a:p>
+          <a:p>
+            <a:pPr lvl="1"/>
+            <a:r>
+              <a:rPr lang="pt-BR" sz="1800" b="1" dirty="0"/>
+              <a:t>%c </a:t>
+            </a:r>
+            <a:r>
+              <a:rPr lang="pt-BR" sz="1800" dirty="0">
+                <a:latin typeface="Calibri" panose="020F0502020204030204" pitchFamily="34" charset="0"/>
+                <a:ea typeface="Calibri" panose="020F0502020204030204" pitchFamily="34" charset="0"/>
+                <a:cs typeface="Calibri" panose="020F0502020204030204" pitchFamily="34" charset="0"/>
+              </a:rPr>
+              <a:t>→</a:t>
+            </a:r>
+            <a:r>
+              <a:rPr lang="pt-BR" sz="1800" b="1" dirty="0">
+                <a:latin typeface="Calibri" panose="020F0502020204030204" pitchFamily="34" charset="0"/>
+                <a:ea typeface="Calibri" panose="020F0502020204030204" pitchFamily="34" charset="0"/>
+                <a:cs typeface="Calibri" panose="020F0502020204030204" pitchFamily="34" charset="0"/>
+              </a:rPr>
+              <a:t> </a:t>
+            </a:r>
+            <a:r>
+              <a:rPr lang="pt-BR" sz="1800" dirty="0"/>
+              <a:t>Um único caractere</a:t>
+            </a:r>
+            <a:endParaRPr lang="pt-BR" sz="1800" b="1" dirty="0"/>
+          </a:p>
+          <a:p>
+            <a:pPr lvl="1"/>
+            <a:r>
+              <a:rPr lang="pt-BR" sz="1800" b="1" dirty="0"/>
+              <a:t>%s </a:t>
+            </a:r>
+            <a:r>
+              <a:rPr lang="pt-BR" sz="1800" dirty="0">
+                <a:latin typeface="Calibri" panose="020F0502020204030204" pitchFamily="34" charset="0"/>
+                <a:ea typeface="Calibri" panose="020F0502020204030204" pitchFamily="34" charset="0"/>
+                <a:cs typeface="Calibri" panose="020F0502020204030204" pitchFamily="34" charset="0"/>
+              </a:rPr>
+              <a:t>→</a:t>
+            </a:r>
+            <a:r>
+              <a:rPr lang="pt-BR" sz="1800" b="1" dirty="0">
+                <a:latin typeface="Calibri" panose="020F0502020204030204" pitchFamily="34" charset="0"/>
+                <a:ea typeface="Calibri" panose="020F0502020204030204" pitchFamily="34" charset="0"/>
+                <a:cs typeface="Calibri" panose="020F0502020204030204" pitchFamily="34" charset="0"/>
+              </a:rPr>
+              <a:t> </a:t>
+            </a:r>
+            <a:r>
+              <a:rPr lang="pt-BR" sz="1800" dirty="0"/>
+              <a:t>Cadeia de caracteres</a:t>
+            </a:r>
+            <a:endParaRPr lang="pt-BR" sz="1800" b="1" dirty="0"/>
+          </a:p>
+          <a:p>
+            <a:pPr lvl="1"/>
+            <a:r>
+              <a:rPr lang="pt-BR" sz="1800" b="1" dirty="0"/>
+              <a:t>%u </a:t>
+            </a:r>
+            <a:r>
+              <a:rPr lang="pt-BR" sz="1800" dirty="0">
+                <a:latin typeface="Calibri" panose="020F0502020204030204" pitchFamily="34" charset="0"/>
+                <a:ea typeface="Calibri" panose="020F0502020204030204" pitchFamily="34" charset="0"/>
+                <a:cs typeface="Calibri" panose="020F0502020204030204" pitchFamily="34" charset="0"/>
+              </a:rPr>
+              <a:t>→</a:t>
+            </a:r>
+            <a:r>
+              <a:rPr lang="pt-BR" sz="1800" b="1" dirty="0">
+                <a:latin typeface="Calibri" panose="020F0502020204030204" pitchFamily="34" charset="0"/>
+                <a:ea typeface="Calibri" panose="020F0502020204030204" pitchFamily="34" charset="0"/>
+                <a:cs typeface="Calibri" panose="020F0502020204030204" pitchFamily="34" charset="0"/>
+              </a:rPr>
+              <a:t> </a:t>
+            </a:r>
+            <a:r>
+              <a:rPr lang="pt-BR" sz="1800" dirty="0"/>
+              <a:t>Número decimal sem sinal</a:t>
+            </a:r>
+            <a:endParaRPr lang="pt-BR" sz="1800" b="1" dirty="0"/>
+          </a:p>
+          <a:p>
+            <a:pPr lvl="1"/>
+            <a:r>
+              <a:rPr lang="pt-BR" sz="1800" b="1" dirty="0"/>
+              <a:t>%o </a:t>
+            </a:r>
+            <a:r>
+              <a:rPr lang="pt-BR" sz="1800" dirty="0">
+                <a:latin typeface="Calibri" panose="020F0502020204030204" pitchFamily="34" charset="0"/>
+                <a:ea typeface="Calibri" panose="020F0502020204030204" pitchFamily="34" charset="0"/>
+                <a:cs typeface="Calibri" panose="020F0502020204030204" pitchFamily="34" charset="0"/>
+              </a:rPr>
+              <a:t>→</a:t>
+            </a:r>
+            <a:r>
+              <a:rPr lang="pt-BR" sz="1800" b="1" dirty="0">
+                <a:latin typeface="Calibri" panose="020F0502020204030204" pitchFamily="34" charset="0"/>
+                <a:ea typeface="Calibri" panose="020F0502020204030204" pitchFamily="34" charset="0"/>
+                <a:cs typeface="Calibri" panose="020F0502020204030204" pitchFamily="34" charset="0"/>
+              </a:rPr>
+              <a:t> </a:t>
+            </a:r>
+            <a:r>
+              <a:rPr lang="pt-BR" sz="1800" dirty="0"/>
+              <a:t>Número em formato octal</a:t>
+            </a:r>
+            <a:endParaRPr lang="pt-BR" sz="1800" b="1" dirty="0"/>
+          </a:p>
+          <a:p>
+            <a:pPr lvl="1"/>
+            <a:r>
+              <a:rPr lang="pt-BR" sz="1800" b="1" dirty="0"/>
+              <a:t>%x </a:t>
+            </a:r>
+            <a:r>
+              <a:rPr lang="pt-BR" sz="1800" dirty="0">
+                <a:latin typeface="Calibri" panose="020F0502020204030204" pitchFamily="34" charset="0"/>
+                <a:ea typeface="Calibri" panose="020F0502020204030204" pitchFamily="34" charset="0"/>
+                <a:cs typeface="Calibri" panose="020F0502020204030204" pitchFamily="34" charset="0"/>
+              </a:rPr>
+              <a:t>→ </a:t>
+            </a:r>
+            <a:r>
+              <a:rPr lang="pt-BR" sz="1800" dirty="0"/>
+              <a:t>Número em formato hexadecimal</a:t>
+            </a:r>
+          </a:p>
+          <a:p>
+            <a:pPr lvl="1"/>
+            <a:r>
+              <a:rPr lang="pt-BR" sz="1800" b="1" dirty="0"/>
+              <a:t>%p </a:t>
+            </a:r>
+            <a:r>
+              <a:rPr lang="pt-BR" sz="1800" dirty="0">
+                <a:latin typeface="Calibri" panose="020F0502020204030204" pitchFamily="34" charset="0"/>
+                <a:ea typeface="Calibri" panose="020F0502020204030204" pitchFamily="34" charset="0"/>
+                <a:cs typeface="Calibri" panose="020F0502020204030204" pitchFamily="34" charset="0"/>
+              </a:rPr>
+              <a:t>→ </a:t>
+            </a:r>
+            <a:r>
+              <a:rPr lang="pt-BR" sz="1800" dirty="0"/>
+              <a:t>Endereço de memória de um ponteiro</a:t>
             </a:r>
           </a:p>
           <a:p>
             <a:endParaRPr lang="pt-BR" sz="2200" dirty="0"/>
-          </a:p>
-          <a:p>
-            <a:r>
-              <a:rPr lang="pt-BR" sz="2200" dirty="0"/>
-              <a:t>Os números </a:t>
-            </a:r>
-            <a:r>
-              <a:rPr lang="pt-BR" sz="2200" dirty="0" err="1"/>
-              <a:t>float</a:t>
-            </a:r>
-            <a:r>
-              <a:rPr lang="pt-BR" sz="2200" dirty="0"/>
-              <a:t> já possuem nativamente um bit dedicado ao sinal.</a:t>
-            </a:r>
-          </a:p>
-          <a:p>
-            <a:endParaRPr lang="pt-BR" sz="2200" dirty="0"/>
-          </a:p>
-          <a:p>
-            <a:r>
-              <a:rPr lang="pt-BR" sz="2200" dirty="0"/>
-              <a:t> Não existe “</a:t>
-            </a:r>
-            <a:r>
-              <a:rPr lang="pt-BR" sz="2200" i="1" dirty="0"/>
-              <a:t>short </a:t>
-            </a:r>
-            <a:r>
-              <a:rPr lang="pt-BR" sz="2200" i="1" dirty="0" err="1"/>
-              <a:t>float</a:t>
-            </a:r>
-            <a:r>
-              <a:rPr lang="pt-BR" sz="2200" i="1" dirty="0"/>
-              <a:t>” </a:t>
-            </a:r>
-            <a:r>
-              <a:rPr lang="pt-BR" sz="2200" dirty="0"/>
-              <a:t>em C, mas a linguagem permite o uso de “</a:t>
-            </a:r>
-            <a:r>
-              <a:rPr lang="pt-BR" sz="2200" i="1" dirty="0" err="1"/>
-              <a:t>long</a:t>
-            </a:r>
-            <a:r>
-              <a:rPr lang="pt-BR" sz="2200" i="1" dirty="0"/>
-              <a:t> </a:t>
-            </a:r>
-            <a:r>
-              <a:rPr lang="pt-BR" sz="2200" i="1" dirty="0" err="1"/>
-              <a:t>double</a:t>
-            </a:r>
-            <a:r>
-              <a:rPr lang="pt-BR" sz="2200" i="1" dirty="0"/>
-              <a:t>” </a:t>
-            </a:r>
-            <a:r>
-              <a:rPr lang="pt-BR" sz="2200" dirty="0"/>
-              <a:t>para criar um tipo de ponto flutuante com precisão ainda maior que o “</a:t>
-            </a:r>
-            <a:r>
-              <a:rPr lang="pt-BR" sz="2200" i="1" dirty="0" err="1"/>
-              <a:t>double</a:t>
-            </a:r>
-            <a:r>
-              <a:rPr lang="pt-BR" sz="2200" i="1" dirty="0"/>
-              <a:t>”</a:t>
-            </a:r>
           </a:p>
         </p:txBody>
       </p:sp>
     </p:spTree>
     <p:extLst>
       <p:ext uri="{BB962C8B-B14F-4D97-AF65-F5344CB8AC3E}">
-        <p14:creationId xmlns:p14="http://schemas.microsoft.com/office/powerpoint/2010/main" val="2701370184"/>
+        <p14:creationId xmlns:p14="http://schemas.microsoft.com/office/powerpoint/2010/main" val="2602179673"/>
       </p:ext>
     </p:extLst>
   </p:cSld>
@@ -9267,312 +9357,6 @@
 </file>
 
 <file path=ppt/slides/slide6.xml><?xml version="1.0" encoding="utf-8"?>
-<p:sld xmlns:a="http://schemas.openxmlformats.org/drawingml/2006/main" xmlns:r="http://schemas.openxmlformats.org/officeDocument/2006/relationships" xmlns:p="http://schemas.openxmlformats.org/presentationml/2006/main">
-  <p:cSld>
-    <p:spTree>
-      <p:nvGrpSpPr>
-        <p:cNvPr id="1" name="">
-          <a:extLst>
-            <a:ext uri="{FF2B5EF4-FFF2-40B4-BE49-F238E27FC236}">
-              <a16:creationId xmlns:a16="http://schemas.microsoft.com/office/drawing/2014/main" id="{848E91F0-2674-868E-FFA4-64084888BB4F}"/>
-            </a:ext>
-          </a:extLst>
-        </p:cNvPr>
-        <p:cNvGrpSpPr/>
-        <p:nvPr/>
-      </p:nvGrpSpPr>
-      <p:grpSpPr>
-        <a:xfrm>
-          <a:off x="0" y="0"/>
-          <a:ext cx="0" cy="0"/>
-          <a:chOff x="0" y="0"/>
-          <a:chExt cx="0" cy="0"/>
-        </a:xfrm>
-      </p:grpSpPr>
-      <p:sp>
-        <p:nvSpPr>
-          <p:cNvPr id="5" name="Retângulo 4">
-            <a:extLst>
-              <a:ext uri="{FF2B5EF4-FFF2-40B4-BE49-F238E27FC236}">
-                <a16:creationId xmlns:a16="http://schemas.microsoft.com/office/drawing/2014/main" id="{20A0ACDA-A859-AA78-DED9-B4571B1C18EA}"/>
-              </a:ext>
-            </a:extLst>
-          </p:cNvPr>
-          <p:cNvSpPr/>
-          <p:nvPr/>
-        </p:nvSpPr>
-        <p:spPr>
-          <a:xfrm>
-            <a:off x="0" y="-2"/>
-            <a:ext cx="12192000" cy="1325563"/>
-          </a:xfrm>
-          <a:prstGeom prst="rect">
-            <a:avLst/>
-          </a:prstGeom>
-          <a:solidFill>
-            <a:srgbClr val="418AB3"/>
-          </a:solidFill>
-          <a:ln>
-            <a:solidFill>
-              <a:srgbClr val="418AB3"/>
-            </a:solidFill>
-          </a:ln>
-        </p:spPr>
-        <p:style>
-          <a:lnRef idx="2">
-            <a:schemeClr val="accent1">
-              <a:shade val="15000"/>
-            </a:schemeClr>
-          </a:lnRef>
-          <a:fillRef idx="1">
-            <a:schemeClr val="accent1"/>
-          </a:fillRef>
-          <a:effectRef idx="0">
-            <a:schemeClr val="accent1"/>
-          </a:effectRef>
-          <a:fontRef idx="minor">
-            <a:schemeClr val="lt1"/>
-          </a:fontRef>
-        </p:style>
-        <p:txBody>
-          <a:bodyPr rtlCol="0" anchor="ctr"/>
-          <a:lstStyle/>
-          <a:p>
-            <a:pPr algn="ctr"/>
-            <a:endParaRPr lang="pt-BR" dirty="0"/>
-          </a:p>
-        </p:txBody>
-      </p:sp>
-      <p:sp>
-        <p:nvSpPr>
-          <p:cNvPr id="2" name="Título 1">
-            <a:extLst>
-              <a:ext uri="{FF2B5EF4-FFF2-40B4-BE49-F238E27FC236}">
-                <a16:creationId xmlns:a16="http://schemas.microsoft.com/office/drawing/2014/main" id="{04307541-C1F5-FF3B-76EF-55C16BA44BCE}"/>
-              </a:ext>
-            </a:extLst>
-          </p:cNvPr>
-          <p:cNvSpPr>
-            <a:spLocks noGrp="1"/>
-          </p:cNvSpPr>
-          <p:nvPr>
-            <p:ph type="title"/>
-          </p:nvPr>
-        </p:nvSpPr>
-        <p:spPr>
-          <a:xfrm>
-            <a:off x="0" y="-1"/>
-            <a:ext cx="12192000" cy="1325563"/>
-          </a:xfrm>
-        </p:spPr>
-        <p:txBody>
-          <a:bodyPr/>
-          <a:lstStyle/>
-          <a:p>
-            <a:pPr algn="ctr"/>
-            <a:r>
-              <a:rPr lang="pt-BR" dirty="0">
-                <a:solidFill>
-                  <a:schemeClr val="bg1"/>
-                </a:solidFill>
-              </a:rPr>
-              <a:t>Prática 3 - Notas</a:t>
-            </a:r>
-          </a:p>
-        </p:txBody>
-      </p:sp>
-      <p:sp>
-        <p:nvSpPr>
-          <p:cNvPr id="12" name="AutoShape 6" descr="Lógica Proposicional x Lógica de Argumento ⋆ Colaborae">
-            <a:extLst>
-              <a:ext uri="{FF2B5EF4-FFF2-40B4-BE49-F238E27FC236}">
-                <a16:creationId xmlns:a16="http://schemas.microsoft.com/office/drawing/2014/main" id="{B577B007-5427-4BC5-AC9A-220DABF796DC}"/>
-              </a:ext>
-            </a:extLst>
-          </p:cNvPr>
-          <p:cNvSpPr>
-            <a:spLocks noChangeAspect="1" noChangeArrowheads="1"/>
-          </p:cNvSpPr>
-          <p:nvPr/>
-        </p:nvSpPr>
-        <p:spPr bwMode="auto">
-          <a:xfrm>
-            <a:off x="5943600" y="-1707776"/>
-            <a:ext cx="5289176" cy="5289176"/>
-          </a:xfrm>
-          <a:prstGeom prst="rect">
-            <a:avLst/>
-          </a:prstGeom>
-          <a:noFill/>
-          <a:extLst>
-            <a:ext uri="{909E8E84-426E-40DD-AFC4-6F175D3DCCD1}">
-              <a14:hiddenFill xmlns:a14="http://schemas.microsoft.com/office/drawing/2010/main">
-                <a:solidFill>
-                  <a:srgbClr val="FFFFFF"/>
-                </a:solidFill>
-              </a14:hiddenFill>
-            </a:ext>
-          </a:extLst>
-        </p:spPr>
-        <p:txBody>
-          <a:bodyPr vert="horz" wrap="square" lIns="91440" tIns="45720" rIns="91440" bIns="45720" numCol="1" anchor="t" anchorCtr="0" compatLnSpc="1">
-            <a:prstTxWarp prst="textNoShape">
-              <a:avLst/>
-            </a:prstTxWarp>
-          </a:bodyPr>
-          <a:lstStyle/>
-          <a:p>
-            <a:endParaRPr lang="pt-BR"/>
-          </a:p>
-        </p:txBody>
-      </p:sp>
-      <p:sp>
-        <p:nvSpPr>
-          <p:cNvPr id="4" name="Espaço Reservado para Conteúdo 3">
-            <a:extLst>
-              <a:ext uri="{FF2B5EF4-FFF2-40B4-BE49-F238E27FC236}">
-                <a16:creationId xmlns:a16="http://schemas.microsoft.com/office/drawing/2014/main" id="{A9B0E50A-ADBD-69F2-8EEE-3C0CEEC4C1AE}"/>
-              </a:ext>
-            </a:extLst>
-          </p:cNvPr>
-          <p:cNvSpPr>
-            <a:spLocks noGrp="1"/>
-          </p:cNvSpPr>
-          <p:nvPr>
-            <p:ph idx="1"/>
-          </p:nvPr>
-        </p:nvSpPr>
-        <p:spPr>
-          <a:xfrm>
-            <a:off x="838200" y="1622424"/>
-            <a:ext cx="10515600" cy="5032375"/>
-          </a:xfrm>
-        </p:spPr>
-        <p:txBody>
-          <a:bodyPr/>
-          <a:lstStyle/>
-          <a:p>
-            <a:r>
-              <a:rPr lang="pt-BR" sz="2400" b="1" dirty="0"/>
-              <a:t>Programa: Operadores aritméticos </a:t>
-            </a:r>
-          </a:p>
-          <a:p>
-            <a:endParaRPr lang="pt-BR" sz="2400" dirty="0"/>
-          </a:p>
-          <a:p>
-            <a:r>
-              <a:rPr lang="pt-BR" sz="2400" dirty="0"/>
-              <a:t>#include &lt;</a:t>
-            </a:r>
-            <a:r>
-              <a:rPr lang="pt-BR" sz="2400" dirty="0" err="1"/>
-              <a:t>locale.h</a:t>
-            </a:r>
-            <a:r>
-              <a:rPr lang="pt-BR" sz="2400" dirty="0"/>
-              <a:t>&gt;: serve para configurar a localização e o idioma de um programa.</a:t>
-            </a:r>
-          </a:p>
-          <a:p>
-            <a:endParaRPr lang="pt-BR" sz="2400" dirty="0"/>
-          </a:p>
-          <a:p>
-            <a:pPr lvl="1"/>
-            <a:r>
-              <a:rPr lang="pt-BR" sz="2200" b="1" dirty="0" err="1"/>
-              <a:t>setlocale</a:t>
-            </a:r>
-            <a:r>
-              <a:rPr lang="pt-BR" sz="2200" b="1" dirty="0"/>
-              <a:t>(): </a:t>
-            </a:r>
-            <a:r>
-              <a:rPr lang="pt-BR" sz="2200" dirty="0"/>
-              <a:t>Altera ou consulta a categoria de idioma do programa. O uso mais comum para o português é </a:t>
-            </a:r>
-            <a:r>
-              <a:rPr lang="pt-BR" sz="2200" i="1" dirty="0" err="1"/>
-              <a:t>setlocale</a:t>
-            </a:r>
-            <a:r>
-              <a:rPr lang="pt-BR" sz="2200" i="1" dirty="0"/>
-              <a:t>(LC_ALL, "</a:t>
-            </a:r>
-            <a:r>
-              <a:rPr lang="pt-BR" sz="2200" i="1" dirty="0" err="1"/>
-              <a:t>Portuguese</a:t>
-            </a:r>
-            <a:r>
-              <a:rPr lang="pt-BR" sz="2200" i="1" dirty="0"/>
-              <a:t>")</a:t>
-            </a:r>
-            <a:r>
-              <a:rPr lang="pt-BR" sz="2200" dirty="0"/>
-              <a:t>; ou </a:t>
-            </a:r>
-            <a:r>
-              <a:rPr lang="pt-BR" sz="2200" i="1" dirty="0" err="1"/>
-              <a:t>setlocale</a:t>
-            </a:r>
-            <a:r>
-              <a:rPr lang="pt-BR" sz="2200" i="1" dirty="0"/>
-              <a:t>(LC_ALL, "")</a:t>
-            </a:r>
-            <a:r>
-              <a:rPr lang="pt-BR" sz="2200" dirty="0"/>
-              <a:t>; para adotar o padrão do sistema operacional.</a:t>
-            </a:r>
-          </a:p>
-          <a:p>
-            <a:pPr marL="457200" lvl="1" indent="0">
-              <a:buNone/>
-            </a:pPr>
-            <a:endParaRPr lang="pt-BR" sz="2200" dirty="0"/>
-          </a:p>
-          <a:p>
-            <a:pPr lvl="1"/>
-            <a:r>
-              <a:rPr lang="pt-BR" sz="2200" b="1" dirty="0"/>
-              <a:t>LC_ALL: </a:t>
-            </a:r>
-            <a:r>
-              <a:rPr lang="pt-BR" sz="2200" dirty="0"/>
-              <a:t>Macro usada na </a:t>
-            </a:r>
-            <a:r>
-              <a:rPr lang="pt-BR" sz="2200" i="1" dirty="0"/>
-              <a:t>função </a:t>
-            </a:r>
-            <a:r>
-              <a:rPr lang="pt-BR" sz="2200" i="1" dirty="0" err="1"/>
-              <a:t>setlocale</a:t>
-            </a:r>
-            <a:r>
-              <a:rPr lang="pt-BR" sz="2200" i="1" dirty="0"/>
-              <a:t>(...)</a:t>
-            </a:r>
-            <a:r>
-              <a:rPr lang="pt-BR" sz="2200" dirty="0"/>
-              <a:t> para aplicar a configuração a todas as categorias de localização do programa.</a:t>
-            </a:r>
-          </a:p>
-        </p:txBody>
-      </p:sp>
-    </p:spTree>
-    <p:extLst>
-      <p:ext uri="{BB962C8B-B14F-4D97-AF65-F5344CB8AC3E}">
-        <p14:creationId xmlns:p14="http://schemas.microsoft.com/office/powerpoint/2010/main" val="2034901250"/>
-      </p:ext>
-    </p:extLst>
-  </p:cSld>
-  <p:clrMapOvr>
-    <a:masterClrMapping/>
-  </p:clrMapOvr>
-</p:sld>
-</file>
-
-<file path=ppt/slides/slide7.xml><?xml version="1.0" encoding="utf-8"?>
 <p:sld xmlns:a="http://schemas.openxmlformats.org/drawingml/2006/main" xmlns:r="http://schemas.openxmlformats.org/officeDocument/2006/relationships" xmlns:p="http://schemas.openxmlformats.org/presentationml/2006/main">
   <p:cSld>
     <p:spTree>

</xml_diff>